<commit_message>
Record hosted #18 final-closure evidence for Product Leadership review.
Co-authored-by: Cursor <cursoragent@cursor.com>
</commit_message>
<xml_diff>
--- a/docs/private-beta/hosted-ux-qa/supreme-ai/Supreme-AI-Board.pptx
+++ b/docs/private-beta/hosted-ux-qa/supreme-ai/Supreme-AI-Board.pptx
@@ -607,7 +607,7 @@
                 </a:solidFill>
                 <a:latin typeface="Calibri" pitchFamily="34" charset="0"/>
               </a:rPr>
-              <a:t xml:space="preserve">1</a:t>
+              <a:t xml:space="preserve">2</a:t>
             </a:r>
           </a:p>
         </p:txBody>
@@ -971,6 +971,39 @@
                 <a:latin typeface="Calibri" pitchFamily="34" charset="0"/>
               </a:rPr>
               <a:t xml:space="preserve">REG-00001 EU AI Act · IN_REVIEW</a:t>
+            </a:r>
+          </a:p>
+        </p:txBody>
+      </p:sp>
+      <p:sp>
+        <p:nvSpPr>
+          <p:cNvPr id="61" name="n61"/>
+          <p:cNvSpPr txBox="1"/>
+          <p:nvPr/>
+        </p:nvSpPr>
+        <p:spPr>
+          <a:xfrm>
+            <a:off x="420000" y="3590000"/>
+            <a:ext cx="11300000" cy="330000"/>
+          </a:xfrm>
+          <a:prstGeom prst="rect">
+            <a:avLst/>
+          </a:prstGeom>
+          <a:noFill/>
+        </p:spPr>
+        <p:txBody>
+          <a:bodyPr wrap="square" anchor="t" lIns="45720" tIns="8000" rIns="45720" bIns="8000"/>
+          <a:lstStyle/>
+          <a:p>
+            <a:pPr algn="l"/>
+            <a:r>
+              <a:rPr lang="en-US" sz="1300" b="0" dirty="0">
+                <a:solidFill>
+                  <a:srgbClr val="0F172A"/>
+                </a:solidFill>
+                <a:latin typeface="Calibri" pitchFamily="34" charset="0"/>
+              </a:rPr>
+              <a:t xml:space="preserve">REG-00002 EU AI Act · IN_REVIEW</a:t>
             </a:r>
           </a:p>
         </p:txBody>
@@ -1293,6 +1326,39 @@
       </p:sp>
       <p:sp>
         <p:nvSpPr>
+          <p:cNvPr id="22" name="n22"/>
+          <p:cNvSpPr txBox="1"/>
+          <p:nvPr/>
+        </p:nvSpPr>
+        <p:spPr>
+          <a:xfrm>
+            <a:off x="420000" y="2480000"/>
+            <a:ext cx="11300000" cy="330000"/>
+          </a:xfrm>
+          <a:prstGeom prst="rect">
+            <a:avLst/>
+          </a:prstGeom>
+          <a:noFill/>
+        </p:spPr>
+        <p:txBody>
+          <a:bodyPr wrap="square" anchor="t" lIns="45720" tIns="8000" rIns="45720" bIns="8000"/>
+          <a:lstStyle/>
+          <a:p>
+            <a:pPr algn="l"/>
+            <a:r>
+              <a:rPr lang="en-US" sz="1300" b="0" dirty="0">
+                <a:solidFill>
+                  <a:srgbClr val="0F172A"/>
+                </a:solidFill>
+                <a:latin typeface="Calibri" pitchFamily="34" charset="0"/>
+              </a:rPr>
+              <a:t xml:space="preserve">AIN-00002 Open incident — AIN-00002 remains open.</a:t>
+            </a:r>
+          </a:p>
+        </p:txBody>
+      </p:sp>
+      <p:sp>
+        <p:nvSpPr>
           <p:cNvPr id="900" name="ft"/>
           <p:cNvSpPr/>
           <p:nvPr/>
@@ -1609,6 +1675,39 @@
       </p:sp>
       <p:sp>
         <p:nvSpPr>
+          <p:cNvPr id="22" name="n22"/>
+          <p:cNvSpPr txBox="1"/>
+          <p:nvPr/>
+        </p:nvSpPr>
+        <p:spPr>
+          <a:xfrm>
+            <a:off x="420000" y="2480000"/>
+            <a:ext cx="11300000" cy="330000"/>
+          </a:xfrm>
+          <a:prstGeom prst="rect">
+            <a:avLst/>
+          </a:prstGeom>
+          <a:noFill/>
+        </p:spPr>
+        <p:txBody>
+          <a:bodyPr wrap="square" anchor="t" lIns="45720" tIns="8000" rIns="45720" bIns="8000"/>
+          <a:lstStyle/>
+          <a:p>
+            <a:pPr algn="l"/>
+            <a:r>
+              <a:rPr lang="en-US" sz="1300" b="0" dirty="0">
+                <a:solidFill>
+                  <a:srgbClr val="0F172A"/>
+                </a:solidFill>
+                <a:latin typeface="Calibri" pitchFamily="34" charset="0"/>
+              </a:rPr>
+              <a:t xml:space="preserve">3. Review AIN-00002 — Open incident. AIN-00002 remains open.</a:t>
+            </a:r>
+          </a:p>
+        </p:txBody>
+      </p:sp>
+      <p:sp>
+        <p:nvSpPr>
           <p:cNvPr id="80" name="t80"/>
           <p:cNvSpPr txBox="1"/>
           <p:nvPr/>
@@ -2248,7 +2347,7 @@
                 </a:solidFill>
                 <a:latin typeface="Calibri" pitchFamily="34" charset="0"/>
               </a:rPr>
-              <a:t xml:space="preserve">1</a:t>
+              <a:t xml:space="preserve">2</a:t>
             </a:r>
           </a:p>
         </p:txBody>
@@ -2392,7 +2491,7 @@
         <p:spPr>
           <a:xfrm>
             <a:off x="3720000" y="3660000"/>
-            <a:ext cx="5200000" cy="160000"/>
+            <a:ext cx="2600000" cy="160000"/>
           </a:xfrm>
           <a:prstGeom prst="roundRect">
             <a:avLst>
@@ -2632,7 +2731,7 @@
                 </a:solidFill>
                 <a:latin typeface="Calibri" pitchFamily="34" charset="0"/>
               </a:rPr>
-              <a:t xml:space="preserve">Open incidents 1</a:t>
+              <a:t xml:space="preserve">Open incidents 2</a:t>
             </a:r>
           </a:p>
         </p:txBody>
@@ -3208,7 +3307,7 @@
                 </a:solidFill>
                 <a:latin typeface="Calibri" pitchFamily="34" charset="0"/>
               </a:rPr>
-              <a:t xml:space="preserve">1</a:t>
+              <a:t xml:space="preserve">2</a:t>
             </a:r>
           </a:p>
         </p:txBody>
@@ -3373,7 +3472,7 @@
                 </a:solidFill>
                 <a:latin typeface="Calibri" pitchFamily="34" charset="0"/>
               </a:rPr>
-              <a:t xml:space="preserve">AI-00001 Claims triage assistant · APPROVED · NOT_CLASSIFIED</a:t>
+              <a:t xml:space="preserve">AI-00001 Claims triage assistant · Approved · Not Classified</a:t>
             </a:r>
           </a:p>
         </p:txBody>
@@ -3887,7 +3986,7 @@
                 </a:solidFill>
                 <a:latin typeface="Calibri" pitchFamily="34" charset="0"/>
               </a:rPr>
-              <a:t xml:space="preserve">0</a:t>
+              <a:t xml:space="preserve">1</a:t>
             </a:r>
           </a:p>
         </p:txBody>
@@ -5759,7 +5858,7 @@
                 </a:solidFill>
                 <a:latin typeface="Calibri" pitchFamily="34" charset="0"/>
               </a:rPr>
-              <a:t xml:space="preserve">0</a:t>
+              <a:t xml:space="preserve">1</a:t>
             </a:r>
           </a:p>
         </p:txBody>
@@ -5858,7 +5957,7 @@
                 </a:solidFill>
                 <a:latin typeface="Calibri" pitchFamily="34" charset="0"/>
               </a:rPr>
-              <a:t xml:space="preserve">1</a:t>
+              <a:t xml:space="preserve">3</a:t>
             </a:r>
           </a:p>
         </p:txBody>
@@ -6103,6 +6202,72 @@
         <p:spPr>
           <a:xfrm>
             <a:off x="420000" y="3200000"/>
+            <a:ext cx="11300000" cy="330000"/>
+          </a:xfrm>
+          <a:prstGeom prst="rect">
+            <a:avLst/>
+          </a:prstGeom>
+          <a:noFill/>
+        </p:spPr>
+        <p:txBody>
+          <a:bodyPr wrap="square" anchor="t" lIns="45720" tIns="8000" rIns="45720" bIns="8000"/>
+          <a:lstStyle/>
+          <a:p>
+            <a:pPr algn="l"/>
+            <a:r>
+              <a:rPr lang="en-US" sz="1300" b="0" dirty="0">
+                <a:solidFill>
+                  <a:srgbClr val="0F172A"/>
+                </a:solidFill>
+                <a:latin typeface="Calibri" pitchFamily="34" charset="0"/>
+              </a:rPr>
+              <a:t xml:space="preserve">AI-00001 Recorded model provider · Unknown / Not recorded</a:t>
+            </a:r>
+          </a:p>
+        </p:txBody>
+      </p:sp>
+      <p:sp>
+        <p:nvSpPr>
+          <p:cNvPr id="61" name="n61"/>
+          <p:cNvSpPr txBox="1"/>
+          <p:nvPr/>
+        </p:nvSpPr>
+        <p:spPr>
+          <a:xfrm>
+            <a:off x="420000" y="3590000"/>
+            <a:ext cx="11300000" cy="330000"/>
+          </a:xfrm>
+          <a:prstGeom prst="rect">
+            <a:avLst/>
+          </a:prstGeom>
+          <a:noFill/>
+        </p:spPr>
+        <p:txBody>
+          <a:bodyPr wrap="square" anchor="t" lIns="45720" tIns="8000" rIns="45720" bIns="8000"/>
+          <a:lstStyle/>
+          <a:p>
+            <a:pPr algn="l"/>
+            <a:r>
+              <a:rPr lang="en-US" sz="1300" b="0" dirty="0">
+                <a:solidFill>
+                  <a:srgbClr val="0F172A"/>
+                </a:solidFill>
+                <a:latin typeface="Calibri" pitchFamily="34" charset="0"/>
+              </a:rPr>
+              <a:t xml:space="preserve">AI-00001 Recorded model provider · Unknown / Not recorded</a:t>
+            </a:r>
+          </a:p>
+        </p:txBody>
+      </p:sp>
+      <p:sp>
+        <p:nvSpPr>
+          <p:cNvPr id="62" name="n62"/>
+          <p:cNvSpPr txBox="1"/>
+          <p:nvPr/>
+        </p:nvSpPr>
+        <p:spPr>
+          <a:xfrm>
+            <a:off x="420000" y="3980000"/>
             <a:ext cx="11300000" cy="330000"/>
           </a:xfrm>
           <a:prstGeom prst="rect">
@@ -6438,7 +6603,7 @@
                 </a:solidFill>
                 <a:latin typeface="Calibri" pitchFamily="34" charset="0"/>
               </a:rPr>
-              <a:t xml:space="preserve">1</a:t>
+              <a:t xml:space="preserve">2</a:t>
             </a:r>
           </a:p>
         </p:txBody>
@@ -6537,7 +6702,7 @@
                 </a:solidFill>
                 <a:latin typeface="Calibri" pitchFamily="34" charset="0"/>
               </a:rPr>
-              <a:t xml:space="preserve">1</a:t>
+              <a:t xml:space="preserve">2</a:t>
             </a:r>
           </a:p>
         </p:txBody>
@@ -6802,6 +6967,39 @@
                 <a:latin typeface="Calibri" pitchFamily="34" charset="0"/>
               </a:rPr>
               <a:t xml:space="preserve">TST-00001 BIAS_FAIRNESS · NOT_TESTED</a:t>
+            </a:r>
+          </a:p>
+        </p:txBody>
+      </p:sp>
+      <p:sp>
+        <p:nvSpPr>
+          <p:cNvPr id="61" name="n61"/>
+          <p:cNvSpPr txBox="1"/>
+          <p:nvPr/>
+        </p:nvSpPr>
+        <p:spPr>
+          <a:xfrm>
+            <a:off x="420000" y="3590000"/>
+            <a:ext cx="11300000" cy="330000"/>
+          </a:xfrm>
+          <a:prstGeom prst="rect">
+            <a:avLst/>
+          </a:prstGeom>
+          <a:noFill/>
+        </p:spPr>
+        <p:txBody>
+          <a:bodyPr wrap="square" anchor="t" lIns="45720" tIns="8000" rIns="45720" bIns="8000"/>
+          <a:lstStyle/>
+          <a:p>
+            <a:pPr algn="l"/>
+            <a:r>
+              <a:rPr lang="en-US" sz="1300" b="0" dirty="0">
+                <a:solidFill>
+                  <a:srgbClr val="0F172A"/>
+                </a:solidFill>
+                <a:latin typeface="Calibri" pitchFamily="34" charset="0"/>
+              </a:rPr>
+              <a:t xml:space="preserve">TST-00002 BIAS_FAIRNESS · NOT_TESTED</a:t>
             </a:r>
           </a:p>
         </p:txBody>
@@ -7117,7 +7315,7 @@
                 </a:solidFill>
                 <a:latin typeface="Calibri" pitchFamily="34" charset="0"/>
               </a:rPr>
-              <a:t xml:space="preserve">1</a:t>
+              <a:t xml:space="preserve">2</a:t>
             </a:r>
           </a:p>
         </p:txBody>
@@ -7216,7 +7414,7 @@
                 </a:solidFill>
                 <a:latin typeface="Calibri" pitchFamily="34" charset="0"/>
               </a:rPr>
-              <a:t xml:space="preserve">1</a:t>
+              <a:t xml:space="preserve">2</a:t>
             </a:r>
           </a:p>
         </p:txBody>
@@ -7481,6 +7679,39 @@
                 <a:latin typeface="Calibri" pitchFamily="34" charset="0"/>
               </a:rPr>
               <a:t xml:space="preserve">AIN-00001 Incorrect claim-routing suggestion · OPEN</a:t>
+            </a:r>
+          </a:p>
+        </p:txBody>
+      </p:sp>
+      <p:sp>
+        <p:nvSpPr>
+          <p:cNvPr id="61" name="n61"/>
+          <p:cNvSpPr txBox="1"/>
+          <p:nvPr/>
+        </p:nvSpPr>
+        <p:spPr>
+          <a:xfrm>
+            <a:off x="420000" y="3590000"/>
+            <a:ext cx="11300000" cy="330000"/>
+          </a:xfrm>
+          <a:prstGeom prst="rect">
+            <a:avLst/>
+          </a:prstGeom>
+          <a:noFill/>
+        </p:spPr>
+        <p:txBody>
+          <a:bodyPr wrap="square" anchor="t" lIns="45720" tIns="8000" rIns="45720" bIns="8000"/>
+          <a:lstStyle/>
+          <a:p>
+            <a:pPr algn="l"/>
+            <a:r>
+              <a:rPr lang="en-US" sz="1300" b="0" dirty="0">
+                <a:solidFill>
+                  <a:srgbClr val="0F172A"/>
+                </a:solidFill>
+                <a:latin typeface="Calibri" pitchFamily="34" charset="0"/>
+              </a:rPr>
+              <a:t xml:space="preserve">AIN-00002 Incorrect claim-routing suggestion · OPEN</a:t>
             </a:r>
           </a:p>
         </p:txBody>

</xml_diff>